<commit_message>
fix(docx/blank): declare common namespaces on <w:document> root
Real Word files declare the full Office namespace set (wps, wp, a, pic,
v, o, w10, ...) on <w:document>; OfficeCli's blank doc only declared
w/mc/w14. Subsequent raw-set injections referencing wps/wp/a (e.g. mc:Choice
Requires="wps" for DrawingML textboxes) failed MarkupCompatibility validation
because the prefix was not in scope at the AlternateContent element.

Mirror the LibreOffice docxexport MainXmlNamespaces() prefix set, and mark
only w14/wp14/w15 as mc:Ignorable (wps/wpg/wpi/wpc are gated by mc:Choice
fallback so they don't need it).

Regenerates examples/* docx outputs to pick up the new namespace block.
</commit_message>
<xml_diff>
--- a/examples/ppt/presentation.pptx
+++ b/examples/ppt/presentation.pptx
@@ -5,12 +5,12 @@
     <p:sldMasterId xmlns:r="http://schemas.openxmlformats.org/officeDocument/2006/relationships" id="2147483648" r:id="rId1"/>
   </p:sldMasterIdLst>
   <p:sldIdLst>
-    <p:sldId id="256" r:id="R604da48190434747"/>
-    <p:sldId id="257" r:id="R12336ed84168439c"/>
-    <p:sldId id="258" r:id="Re626b684d7754d36"/>
-    <p:sldId id="259" r:id="R64b52d03b7b84dda"/>
-    <p:sldId id="260" r:id="Rd0cc7538101045f5"/>
-    <p:sldId id="261" r:id="Reb81dd2cdbe94d5f"/>
+    <p:sldId id="256" r:id="R190dd378ba964bf7"/>
+    <p:sldId id="257" r:id="Rc48f9f23a68c40bb"/>
+    <p:sldId id="258" r:id="R89952375a85248ee"/>
+    <p:sldId id="259" r:id="R0708d1789cfa4f0f"/>
+    <p:sldId id="260" r:id="R79c46e57cc414d93"/>
+    <p:sldId id="261" r:id="Rbe29a3359c264068"/>
   </p:sldIdLst>
   <p:sldSz cx="12192000" cy="6858000"/>
   <p:notesSz cx="6858000" cy="9144000"/>

</xml_diff>